<commit_message>
docs(deck): live URL, Loom placeholder, tenancy and cron wording
Replace the deploy bullet with the live demo URL and a Loom placeholder. Describe tenant isolation
the way README decision 8 does. Describe the nightly run as Vercel Cron and the missing lock.
Rebuilt with npm run deck.

Co-Authored-By: Claude Haiku 5.5 <noreply@anthropic.com>
</commit_message>
<xml_diff>
--- a/docs/renewal-risk-deck.pptx
+++ b/docs/renewal-risk-deck.pptx
@@ -1922,7 +1922,7 @@
                 <a:ea typeface="Calibri" pitchFamily="34" charset="-122"/>
                 <a:cs typeface="Calibri" pitchFamily="34" charset="-120"/>
               </a:rPr>
-              <a:t>2. One scheduler process. A second copy would double-run. Needs a lock per org.</a:t>
+              <a:t>2. The nightly run has no lock. Overlapping runs can send duplicate card reminders. Needs an advisory lock per org.</a:t>
             </a:r>
             <a:endParaRPr lang="en-US" sz="1900" dirty="0"/>
           </a:p>
@@ -1985,7 +1985,28 @@
                 <a:ea typeface="Calibri" pitchFamily="34" charset="-122"/>
                 <a:cs typeface="Calibri" pitchFamily="34" charset="-120"/>
               </a:rPr>
-              <a:t>Next: deploy to a host (needs your choice and approval), connect real sources, and measure whether calls work.</a:t>
+              <a:t>Live demo: https://fello-renewal-risk.vercel.app/</a:t>
+            </a:r>
+            <a:endParaRPr lang="en-US" sz="1900" dirty="0"/>
+          </a:p>
+          <a:p>
+            <a:pPr marL="228600" indent="-228600">
+              <a:spcAft>
+                <a:spcPts val="1000"/>
+              </a:spcAft>
+              <a:buSzPct val="100000"/>
+              <a:buChar char="•"/>
+            </a:pPr>
+            <a:r>
+              <a:rPr lang="en-US" sz="1900" dirty="0">
+                <a:solidFill>
+                  <a:srgbClr val="1C1C1E"/>
+                </a:solidFill>
+                <a:latin typeface="Calibri" pitchFamily="34" charset="0"/>
+                <a:ea typeface="Calibri" pitchFamily="34" charset="-122"/>
+                <a:cs typeface="Calibri" pitchFamily="34" charset="-120"/>
+              </a:rPr>
+              <a:t>Loom walkthrough: LINK_TBD</a:t>
             </a:r>
             <a:endParaRPr lang="en-US" sz="1900" dirty="0"/>
           </a:p>
@@ -2099,7 +2120,7 @@
                 <a:ea typeface="Calibri" pitchFamily="34" charset="-122"/>
                 <a:cs typeface="Calibri" pitchFamily="34" charset="-120"/>
               </a:rPr>
-              <a:t>Each CSM owns about 120 accounts and can make 15–20 calls a week.</a:t>
+              <a:t>Each CSM owns about 120 accounts and can make 15 to 20 calls a week.</a:t>
             </a:r>
             <a:endParaRPr lang="en-US" sz="1900" dirty="0"/>
           </a:p>
@@ -2579,7 +2600,7 @@
                 <a:ea typeface="Calibri" pitchFamily="34" charset="-122"/>
                 <a:cs typeface="Calibri" pitchFamily="34" charset="-120"/>
               </a:rPr>
-              <a:t>A CSM app with tenant isolation enforced in the database, not the app.</a:t>
+              <a:t>A CSM app with tenant isolation. The app's signed session cookie is the trust boundary; Postgres row-level security filters every query as defense in depth.</a:t>
             </a:r>
             <a:endParaRPr lang="en-US" sz="1900" dirty="0"/>
           </a:p>
@@ -3344,7 +3365,7 @@
                           <a:ea typeface="Calibri" pitchFamily="34" charset="-122"/>
                           <a:cs typeface="Calibri" pitchFamily="34" charset="-120"/>
                         </a:rPr>
-                        <a:t>0.71 (0.65–0.85)</a:t>
+                        <a:t>0.71 (0.65 to 0.85)</a:t>
                       </a:r>
                       <a:endParaRPr lang="en-US" sz="1800" dirty="0">
                         <a:latin typeface="Calibri" charset="0"/>
@@ -3409,7 +3430,7 @@
                           <a:ea typeface="Calibri" pitchFamily="34" charset="-122"/>
                           <a:cs typeface="Calibri" pitchFamily="34" charset="-120"/>
                         </a:rPr>
-                        <a:t>0.60 (0.51–0.69)</a:t>
+                        <a:t>0.60 (0.51 to 0.69)</a:t>
                       </a:r>
                       <a:endParaRPr lang="en-US" sz="1800" dirty="0">
                         <a:latin typeface="Calibri" charset="0"/>
@@ -3852,7 +3873,7 @@
                 <a:ea typeface="Calibri" pitchFamily="34" charset="-122"/>
                 <a:cs typeface="Calibri" pitchFamily="34" charset="-120"/>
               </a:rPr>
-              <a:t>Runs nightly without anyone starting it. Verified: a scheduled run fired and published on its own.</a:t>
+              <a:t>Runs nightly on a Vercel Cron schedule (02:00 IST), without anyone starting it.</a:t>
             </a:r>
             <a:endParaRPr lang="en-US" sz="1900" dirty="0"/>
           </a:p>

</xml_diff>